<commit_message>
Update PubMed lymphoma slides 2026-06-07 five papers
</commit_message>
<xml_diff>
--- a/archive/2026-06-07/pubmed-dlbcl-cnsl-btki-2026-06-07.pptx
+++ b/archive/2026-06-07/pubmed-dlbcl-cnsl-btki-2026-06-07.pptx
@@ -5,20 +5,15 @@
     <p:sldMasterId id="2147483648" r:id="rId1"/>
   </p:sldMasterIdLst>
   <p:sldIdLst>
-    <p:sldId id="256" r:id="rId7"/>
-    <p:sldId id="257" r:id="rId8"/>
-    <p:sldId id="258" r:id="rId9"/>
-    <p:sldId id="259" r:id="rId10"/>
-    <p:sldId id="260" r:id="rId11"/>
-    <p:sldId id="261" r:id="rId12"/>
-    <p:sldId id="262" r:id="rId13"/>
-    <p:sldId id="263" r:id="rId14"/>
-    <p:sldId id="264" r:id="rId15"/>
-    <p:sldId id="265" r:id="rId16"/>
-    <p:sldId id="266" r:id="rId17"/>
-    <p:sldId id="267" r:id="rId18"/>
+    <p:sldId id="256" r:id="rId2"/>
+    <p:sldId id="257" r:id="rId3"/>
+    <p:sldId id="258" r:id="rId4"/>
+    <p:sldId id="259" r:id="rId5"/>
+    <p:sldId id="260" r:id="rId6"/>
+    <p:sldId id="261" r:id="rId7"/>
+    <p:sldId id="262" r:id="rId8"/>
   </p:sldIdLst>
-  <p:sldSz cx="12191999" cy="6858000" type="screen4x3"/>
+  <p:sldSz cx="12192000" cy="6858000"/>
   <p:notesSz cx="6858000" cy="9144000"/>
   <p:defaultTextStyle>
     <a:defPPr>
@@ -115,6 +110,22 @@
       </a:defRPr>
     </a:lvl9pPr>
   </p:defaultTextStyle>
+  <p:extLst>
+    <p:ext uri="{EFAFB233-063F-42B5-8137-9DF3F51BA10A}">
+      <p15:sldGuideLst xmlns:p15="http://schemas.microsoft.com/office/powerpoint/2012/main">
+        <p15:guide id="1" orient="horz" pos="2160">
+          <p15:clr>
+            <a:srgbClr val="A4A3A4"/>
+          </p15:clr>
+        </p15:guide>
+        <p15:guide id="2" pos="2880">
+          <p15:clr>
+            <a:srgbClr val="A4A3A4"/>
+          </p15:clr>
+        </p15:guide>
+      </p15:sldGuideLst>
+    </p:ext>
+  </p:extLst>
 </p:presentation>
 </file>
 
@@ -156,10 +167,9 @@
           <a:lstStyle/>
           <a:p>
             <a:r>
-              <a:rPr lang="en-US" smtClean="0"/>
+              <a:rPr lang="en-US"/>
               <a:t>Click to edit Master title style</a:t>
             </a:r>
-            <a:endParaRPr lang="en-US"/>
           </a:p>
         </p:txBody>
       </p:sp>
@@ -275,10 +285,9 @@
           </a:lstStyle>
           <a:p>
             <a:r>
-              <a:rPr lang="en-US" smtClean="0"/>
+              <a:rPr lang="en-US"/>
               <a:t>Click to edit Master subtitle style</a:t>
             </a:r>
-            <a:endParaRPr lang="en-US"/>
           </a:p>
         </p:txBody>
       </p:sp>
@@ -299,7 +308,7 @@
           <a:p>
             <a:fld id="{5BCAD085-E8A6-8845-BD4E-CB4CCA059FC4}" type="datetimeFigureOut">
               <a:rPr lang="en-US" smtClean="0"/>
-              <a:t>1/27/13</a:t>
+              <a:t>6/7/2026</a:t>
             </a:fld>
             <a:endParaRPr lang="en-US"/>
           </a:p>
@@ -393,10 +402,9 @@
           <a:lstStyle/>
           <a:p>
             <a:r>
-              <a:rPr lang="en-US" smtClean="0"/>
+              <a:rPr lang="en-US"/>
               <a:t>Click to edit Master title style</a:t>
             </a:r>
-            <a:endParaRPr lang="en-US"/>
           </a:p>
         </p:txBody>
       </p:sp>
@@ -417,38 +425,37 @@
           <a:p>
             <a:pPr lvl="0"/>
             <a:r>
-              <a:rPr lang="en-US" smtClean="0"/>
+              <a:rPr lang="en-US"/>
               <a:t>Click to edit Master text styles</a:t>
             </a:r>
           </a:p>
           <a:p>
             <a:pPr lvl="1"/>
             <a:r>
-              <a:rPr lang="en-US" smtClean="0"/>
+              <a:rPr lang="en-US"/>
               <a:t>Second level</a:t>
             </a:r>
           </a:p>
           <a:p>
             <a:pPr lvl="2"/>
             <a:r>
-              <a:rPr lang="en-US" smtClean="0"/>
+              <a:rPr lang="en-US"/>
               <a:t>Third level</a:t>
             </a:r>
           </a:p>
           <a:p>
             <a:pPr lvl="3"/>
             <a:r>
-              <a:rPr lang="en-US" smtClean="0"/>
+              <a:rPr lang="en-US"/>
               <a:t>Fourth level</a:t>
             </a:r>
           </a:p>
           <a:p>
             <a:pPr lvl="4"/>
             <a:r>
-              <a:rPr lang="en-US" smtClean="0"/>
+              <a:rPr lang="en-US"/>
               <a:t>Fifth level</a:t>
             </a:r>
-            <a:endParaRPr lang="en-US"/>
           </a:p>
         </p:txBody>
       </p:sp>
@@ -469,7 +476,7 @@
           <a:p>
             <a:fld id="{5BCAD085-E8A6-8845-BD4E-CB4CCA059FC4}" type="datetimeFigureOut">
               <a:rPr lang="en-US" smtClean="0"/>
-              <a:t>1/27/13</a:t>
+              <a:t>6/7/2026</a:t>
             </a:fld>
             <a:endParaRPr lang="en-US"/>
           </a:p>
@@ -568,10 +575,9 @@
           <a:lstStyle/>
           <a:p>
             <a:r>
-              <a:rPr lang="en-US" smtClean="0"/>
+              <a:rPr lang="en-US"/>
               <a:t>Click to edit Master title style</a:t>
             </a:r>
-            <a:endParaRPr lang="en-US"/>
           </a:p>
         </p:txBody>
       </p:sp>
@@ -597,38 +603,37 @@
           <a:p>
             <a:pPr lvl="0"/>
             <a:r>
-              <a:rPr lang="en-US" smtClean="0"/>
+              <a:rPr lang="en-US"/>
               <a:t>Click to edit Master text styles</a:t>
             </a:r>
           </a:p>
           <a:p>
             <a:pPr lvl="1"/>
             <a:r>
-              <a:rPr lang="en-US" smtClean="0"/>
+              <a:rPr lang="en-US"/>
               <a:t>Second level</a:t>
             </a:r>
           </a:p>
           <a:p>
             <a:pPr lvl="2"/>
             <a:r>
-              <a:rPr lang="en-US" smtClean="0"/>
+              <a:rPr lang="en-US"/>
               <a:t>Third level</a:t>
             </a:r>
           </a:p>
           <a:p>
             <a:pPr lvl="3"/>
             <a:r>
-              <a:rPr lang="en-US" smtClean="0"/>
+              <a:rPr lang="en-US"/>
               <a:t>Fourth level</a:t>
             </a:r>
           </a:p>
           <a:p>
             <a:pPr lvl="4"/>
             <a:r>
-              <a:rPr lang="en-US" smtClean="0"/>
+              <a:rPr lang="en-US"/>
               <a:t>Fifth level</a:t>
             </a:r>
-            <a:endParaRPr lang="en-US"/>
           </a:p>
         </p:txBody>
       </p:sp>
@@ -649,7 +654,7 @@
           <a:p>
             <a:fld id="{5BCAD085-E8A6-8845-BD4E-CB4CCA059FC4}" type="datetimeFigureOut">
               <a:rPr lang="en-US" smtClean="0"/>
-              <a:t>1/27/13</a:t>
+              <a:t>6/7/2026</a:t>
             </a:fld>
             <a:endParaRPr lang="en-US"/>
           </a:p>
@@ -743,10 +748,9 @@
           <a:lstStyle/>
           <a:p>
             <a:r>
-              <a:rPr lang="en-US" smtClean="0"/>
+              <a:rPr lang="en-US"/>
               <a:t>Click to edit Master title style</a:t>
             </a:r>
-            <a:endParaRPr lang="en-US"/>
           </a:p>
         </p:txBody>
       </p:sp>
@@ -767,38 +771,37 @@
           <a:p>
             <a:pPr lvl="0"/>
             <a:r>
-              <a:rPr lang="en-US" smtClean="0"/>
+              <a:rPr lang="en-US"/>
               <a:t>Click to edit Master text styles</a:t>
             </a:r>
           </a:p>
           <a:p>
             <a:pPr lvl="1"/>
             <a:r>
-              <a:rPr lang="en-US" smtClean="0"/>
+              <a:rPr lang="en-US"/>
               <a:t>Second level</a:t>
             </a:r>
           </a:p>
           <a:p>
             <a:pPr lvl="2"/>
             <a:r>
-              <a:rPr lang="en-US" smtClean="0"/>
+              <a:rPr lang="en-US"/>
               <a:t>Third level</a:t>
             </a:r>
           </a:p>
           <a:p>
             <a:pPr lvl="3"/>
             <a:r>
-              <a:rPr lang="en-US" smtClean="0"/>
+              <a:rPr lang="en-US"/>
               <a:t>Fourth level</a:t>
             </a:r>
           </a:p>
           <a:p>
             <a:pPr lvl="4"/>
             <a:r>
-              <a:rPr lang="en-US" smtClean="0"/>
+              <a:rPr lang="en-US"/>
               <a:t>Fifth level</a:t>
             </a:r>
-            <a:endParaRPr lang="en-US"/>
           </a:p>
         </p:txBody>
       </p:sp>
@@ -819,7 +822,7 @@
           <a:p>
             <a:fld id="{5BCAD085-E8A6-8845-BD4E-CB4CCA059FC4}" type="datetimeFigureOut">
               <a:rPr lang="en-US" smtClean="0"/>
-              <a:t>1/27/13</a:t>
+              <a:t>6/7/2026</a:t>
             </a:fld>
             <a:endParaRPr lang="en-US"/>
           </a:p>
@@ -922,10 +925,9 @@
           </a:lstStyle>
           <a:p>
             <a:r>
-              <a:rPr lang="en-US" smtClean="0"/>
+              <a:rPr lang="en-US"/>
               <a:t>Click to edit Master title style</a:t>
             </a:r>
-            <a:endParaRPr lang="en-US"/>
           </a:p>
         </p:txBody>
       </p:sp>
@@ -1042,7 +1044,7 @@
           <a:p>
             <a:pPr lvl="0"/>
             <a:r>
-              <a:rPr lang="en-US" smtClean="0"/>
+              <a:rPr lang="en-US"/>
               <a:t>Click to edit Master text styles</a:t>
             </a:r>
           </a:p>
@@ -1065,7 +1067,7 @@
           <a:p>
             <a:fld id="{5BCAD085-E8A6-8845-BD4E-CB4CCA059FC4}" type="datetimeFigureOut">
               <a:rPr lang="en-US" smtClean="0"/>
-              <a:t>1/27/13</a:t>
+              <a:t>6/7/2026</a:t>
             </a:fld>
             <a:endParaRPr lang="en-US"/>
           </a:p>
@@ -1159,10 +1161,9 @@
           <a:lstStyle/>
           <a:p>
             <a:r>
-              <a:rPr lang="en-US" smtClean="0"/>
+              <a:rPr lang="en-US"/>
               <a:t>Click to edit Master title style</a:t>
             </a:r>
-            <a:endParaRPr lang="en-US"/>
           </a:p>
         </p:txBody>
       </p:sp>
@@ -1216,38 +1217,37 @@
           <a:p>
             <a:pPr lvl="0"/>
             <a:r>
-              <a:rPr lang="en-US" smtClean="0"/>
+              <a:rPr lang="en-US"/>
               <a:t>Click to edit Master text styles</a:t>
             </a:r>
           </a:p>
           <a:p>
             <a:pPr lvl="1"/>
             <a:r>
-              <a:rPr lang="en-US" smtClean="0"/>
+              <a:rPr lang="en-US"/>
               <a:t>Second level</a:t>
             </a:r>
           </a:p>
           <a:p>
             <a:pPr lvl="2"/>
             <a:r>
-              <a:rPr lang="en-US" smtClean="0"/>
+              <a:rPr lang="en-US"/>
               <a:t>Third level</a:t>
             </a:r>
           </a:p>
           <a:p>
             <a:pPr lvl="3"/>
             <a:r>
-              <a:rPr lang="en-US" smtClean="0"/>
+              <a:rPr lang="en-US"/>
               <a:t>Fourth level</a:t>
             </a:r>
           </a:p>
           <a:p>
             <a:pPr lvl="4"/>
             <a:r>
-              <a:rPr lang="en-US" smtClean="0"/>
+              <a:rPr lang="en-US"/>
               <a:t>Fifth level</a:t>
             </a:r>
-            <a:endParaRPr lang="en-US"/>
           </a:p>
         </p:txBody>
       </p:sp>
@@ -1301,38 +1301,37 @@
           <a:p>
             <a:pPr lvl="0"/>
             <a:r>
-              <a:rPr lang="en-US" smtClean="0"/>
+              <a:rPr lang="en-US"/>
               <a:t>Click to edit Master text styles</a:t>
             </a:r>
           </a:p>
           <a:p>
             <a:pPr lvl="1"/>
             <a:r>
-              <a:rPr lang="en-US" smtClean="0"/>
+              <a:rPr lang="en-US"/>
               <a:t>Second level</a:t>
             </a:r>
           </a:p>
           <a:p>
             <a:pPr lvl="2"/>
             <a:r>
-              <a:rPr lang="en-US" smtClean="0"/>
+              <a:rPr lang="en-US"/>
               <a:t>Third level</a:t>
             </a:r>
           </a:p>
           <a:p>
             <a:pPr lvl="3"/>
             <a:r>
-              <a:rPr lang="en-US" smtClean="0"/>
+              <a:rPr lang="en-US"/>
               <a:t>Fourth level</a:t>
             </a:r>
           </a:p>
           <a:p>
             <a:pPr lvl="4"/>
             <a:r>
-              <a:rPr lang="en-US" smtClean="0"/>
+              <a:rPr lang="en-US"/>
               <a:t>Fifth level</a:t>
             </a:r>
-            <a:endParaRPr lang="en-US"/>
           </a:p>
         </p:txBody>
       </p:sp>
@@ -1353,7 +1352,7 @@
           <a:p>
             <a:fld id="{5BCAD085-E8A6-8845-BD4E-CB4CCA059FC4}" type="datetimeFigureOut">
               <a:rPr lang="en-US" smtClean="0"/>
-              <a:t>1/27/13</a:t>
+              <a:t>6/7/2026</a:t>
             </a:fld>
             <a:endParaRPr lang="en-US"/>
           </a:p>
@@ -1451,10 +1450,9 @@
           </a:lstStyle>
           <a:p>
             <a:r>
-              <a:rPr lang="en-US" smtClean="0"/>
+              <a:rPr lang="en-US"/>
               <a:t>Click to edit Master title style</a:t>
             </a:r>
-            <a:endParaRPr lang="en-US"/>
           </a:p>
         </p:txBody>
       </p:sp>
@@ -1517,7 +1515,7 @@
           <a:p>
             <a:pPr lvl="0"/>
             <a:r>
-              <a:rPr lang="en-US" smtClean="0"/>
+              <a:rPr lang="en-US"/>
               <a:t>Click to edit Master text styles</a:t>
             </a:r>
           </a:p>
@@ -1573,38 +1571,37 @@
           <a:p>
             <a:pPr lvl="0"/>
             <a:r>
-              <a:rPr lang="en-US" smtClean="0"/>
+              <a:rPr lang="en-US"/>
               <a:t>Click to edit Master text styles</a:t>
             </a:r>
           </a:p>
           <a:p>
             <a:pPr lvl="1"/>
             <a:r>
-              <a:rPr lang="en-US" smtClean="0"/>
+              <a:rPr lang="en-US"/>
               <a:t>Second level</a:t>
             </a:r>
           </a:p>
           <a:p>
             <a:pPr lvl="2"/>
             <a:r>
-              <a:rPr lang="en-US" smtClean="0"/>
+              <a:rPr lang="en-US"/>
               <a:t>Third level</a:t>
             </a:r>
           </a:p>
           <a:p>
             <a:pPr lvl="3"/>
             <a:r>
-              <a:rPr lang="en-US" smtClean="0"/>
+              <a:rPr lang="en-US"/>
               <a:t>Fourth level</a:t>
             </a:r>
           </a:p>
           <a:p>
             <a:pPr lvl="4"/>
             <a:r>
-              <a:rPr lang="en-US" smtClean="0"/>
+              <a:rPr lang="en-US"/>
               <a:t>Fifth level</a:t>
             </a:r>
-            <a:endParaRPr lang="en-US"/>
           </a:p>
         </p:txBody>
       </p:sp>
@@ -1667,7 +1664,7 @@
           <a:p>
             <a:pPr lvl="0"/>
             <a:r>
-              <a:rPr lang="en-US" smtClean="0"/>
+              <a:rPr lang="en-US"/>
               <a:t>Click to edit Master text styles</a:t>
             </a:r>
           </a:p>
@@ -1723,38 +1720,37 @@
           <a:p>
             <a:pPr lvl="0"/>
             <a:r>
-              <a:rPr lang="en-US" smtClean="0"/>
+              <a:rPr lang="en-US"/>
               <a:t>Click to edit Master text styles</a:t>
             </a:r>
           </a:p>
           <a:p>
             <a:pPr lvl="1"/>
             <a:r>
-              <a:rPr lang="en-US" smtClean="0"/>
+              <a:rPr lang="en-US"/>
               <a:t>Second level</a:t>
             </a:r>
           </a:p>
           <a:p>
             <a:pPr lvl="2"/>
             <a:r>
-              <a:rPr lang="en-US" smtClean="0"/>
+              <a:rPr lang="en-US"/>
               <a:t>Third level</a:t>
             </a:r>
           </a:p>
           <a:p>
             <a:pPr lvl="3"/>
             <a:r>
-              <a:rPr lang="en-US" smtClean="0"/>
+              <a:rPr lang="en-US"/>
               <a:t>Fourth level</a:t>
             </a:r>
           </a:p>
           <a:p>
             <a:pPr lvl="4"/>
             <a:r>
-              <a:rPr lang="en-US" smtClean="0"/>
+              <a:rPr lang="en-US"/>
               <a:t>Fifth level</a:t>
             </a:r>
-            <a:endParaRPr lang="en-US"/>
           </a:p>
         </p:txBody>
       </p:sp>
@@ -1775,7 +1771,7 @@
           <a:p>
             <a:fld id="{5BCAD085-E8A6-8845-BD4E-CB4CCA059FC4}" type="datetimeFigureOut">
               <a:rPr lang="en-US" smtClean="0"/>
-              <a:t>1/27/13</a:t>
+              <a:t>6/7/2026</a:t>
             </a:fld>
             <a:endParaRPr lang="en-US"/>
           </a:p>
@@ -1869,10 +1865,9 @@
           <a:lstStyle/>
           <a:p>
             <a:r>
-              <a:rPr lang="en-US" smtClean="0"/>
+              <a:rPr lang="en-US"/>
               <a:t>Click to edit Master title style</a:t>
             </a:r>
-            <a:endParaRPr lang="en-US"/>
           </a:p>
         </p:txBody>
       </p:sp>
@@ -1893,7 +1888,7 @@
           <a:p>
             <a:fld id="{5BCAD085-E8A6-8845-BD4E-CB4CCA059FC4}" type="datetimeFigureOut">
               <a:rPr lang="en-US" smtClean="0"/>
-              <a:t>1/27/13</a:t>
+              <a:t>6/7/2026</a:t>
             </a:fld>
             <a:endParaRPr lang="en-US"/>
           </a:p>
@@ -1988,7 +1983,7 @@
           <a:p>
             <a:fld id="{5BCAD085-E8A6-8845-BD4E-CB4CCA059FC4}" type="datetimeFigureOut">
               <a:rPr lang="en-US" smtClean="0"/>
-              <a:t>1/27/13</a:t>
+              <a:t>6/7/2026</a:t>
             </a:fld>
             <a:endParaRPr lang="en-US"/>
           </a:p>
@@ -2091,10 +2086,9 @@
           </a:lstStyle>
           <a:p>
             <a:r>
-              <a:rPr lang="en-US" smtClean="0"/>
+              <a:rPr lang="en-US"/>
               <a:t>Click to edit Master title style</a:t>
             </a:r>
-            <a:endParaRPr lang="en-US"/>
           </a:p>
         </p:txBody>
       </p:sp>
@@ -2148,38 +2142,37 @@
           <a:p>
             <a:pPr lvl="0"/>
             <a:r>
-              <a:rPr lang="en-US" smtClean="0"/>
+              <a:rPr lang="en-US"/>
               <a:t>Click to edit Master text styles</a:t>
             </a:r>
           </a:p>
           <a:p>
             <a:pPr lvl="1"/>
             <a:r>
-              <a:rPr lang="en-US" smtClean="0"/>
+              <a:rPr lang="en-US"/>
               <a:t>Second level</a:t>
             </a:r>
           </a:p>
           <a:p>
             <a:pPr lvl="2"/>
             <a:r>
-              <a:rPr lang="en-US" smtClean="0"/>
+              <a:rPr lang="en-US"/>
               <a:t>Third level</a:t>
             </a:r>
           </a:p>
           <a:p>
             <a:pPr lvl="3"/>
             <a:r>
-              <a:rPr lang="en-US" smtClean="0"/>
+              <a:rPr lang="en-US"/>
               <a:t>Fourth level</a:t>
             </a:r>
           </a:p>
           <a:p>
             <a:pPr lvl="4"/>
             <a:r>
-              <a:rPr lang="en-US" smtClean="0"/>
+              <a:rPr lang="en-US"/>
               <a:t>Fifth level</a:t>
             </a:r>
-            <a:endParaRPr lang="en-US"/>
           </a:p>
         </p:txBody>
       </p:sp>
@@ -2242,7 +2235,7 @@
           <a:p>
             <a:pPr lvl="0"/>
             <a:r>
-              <a:rPr lang="en-US" smtClean="0"/>
+              <a:rPr lang="en-US"/>
               <a:t>Click to edit Master text styles</a:t>
             </a:r>
           </a:p>
@@ -2265,7 +2258,7 @@
           <a:p>
             <a:fld id="{5BCAD085-E8A6-8845-BD4E-CB4CCA059FC4}" type="datetimeFigureOut">
               <a:rPr lang="en-US" smtClean="0"/>
-              <a:t>1/27/13</a:t>
+              <a:t>6/7/2026</a:t>
             </a:fld>
             <a:endParaRPr lang="en-US"/>
           </a:p>
@@ -2368,10 +2361,9 @@
           </a:lstStyle>
           <a:p>
             <a:r>
-              <a:rPr lang="en-US" smtClean="0"/>
+              <a:rPr lang="en-US"/>
               <a:t>Click to edit Master title style</a:t>
             </a:r>
-            <a:endParaRPr lang="en-US"/>
           </a:p>
         </p:txBody>
       </p:sp>
@@ -2495,7 +2487,7 @@
           <a:p>
             <a:pPr lvl="0"/>
             <a:r>
-              <a:rPr lang="en-US" smtClean="0"/>
+              <a:rPr lang="en-US"/>
               <a:t>Click to edit Master text styles</a:t>
             </a:r>
           </a:p>
@@ -2518,7 +2510,7 @@
           <a:p>
             <a:fld id="{5BCAD085-E8A6-8845-BD4E-CB4CCA059FC4}" type="datetimeFigureOut">
               <a:rPr lang="en-US" smtClean="0"/>
-              <a:t>1/27/13</a:t>
+              <a:t>6/7/2026</a:t>
             </a:fld>
             <a:endParaRPr lang="en-US"/>
           </a:p>
@@ -2627,10 +2619,9 @@
           <a:lstStyle/>
           <a:p>
             <a:r>
-              <a:rPr lang="en-US" smtClean="0"/>
+              <a:rPr lang="en-US"/>
               <a:t>Click to edit Master title style</a:t>
             </a:r>
-            <a:endParaRPr lang="en-US"/>
           </a:p>
         </p:txBody>
       </p:sp>
@@ -2661,38 +2652,37 @@
           <a:p>
             <a:pPr lvl="0"/>
             <a:r>
-              <a:rPr lang="en-US" smtClean="0"/>
+              <a:rPr lang="en-US"/>
               <a:t>Click to edit Master text styles</a:t>
             </a:r>
           </a:p>
           <a:p>
             <a:pPr lvl="1"/>
             <a:r>
-              <a:rPr lang="en-US" smtClean="0"/>
+              <a:rPr lang="en-US"/>
               <a:t>Second level</a:t>
             </a:r>
           </a:p>
           <a:p>
             <a:pPr lvl="2"/>
             <a:r>
-              <a:rPr lang="en-US" smtClean="0"/>
+              <a:rPr lang="en-US"/>
               <a:t>Third level</a:t>
             </a:r>
           </a:p>
           <a:p>
             <a:pPr lvl="3"/>
             <a:r>
-              <a:rPr lang="en-US" smtClean="0"/>
+              <a:rPr lang="en-US"/>
               <a:t>Fourth level</a:t>
             </a:r>
           </a:p>
           <a:p>
             <a:pPr lvl="4"/>
             <a:r>
-              <a:rPr lang="en-US" smtClean="0"/>
+              <a:rPr lang="en-US"/>
               <a:t>Fifth level</a:t>
             </a:r>
-            <a:endParaRPr lang="en-US"/>
           </a:p>
         </p:txBody>
       </p:sp>
@@ -2731,7 +2721,7 @@
           <a:p>
             <a:fld id="{5BCAD085-E8A6-8845-BD4E-CB4CCA059FC4}" type="datetimeFigureOut">
               <a:rPr lang="en-US" smtClean="0"/>
-              <a:t>1/27/13</a:t>
+              <a:t>6/7/2026</a:t>
             </a:fld>
             <a:endParaRPr lang="en-US"/>
           </a:p>
@@ -3090,7 +3080,7 @@
 </file>
 
 <file path=ppt/slides/slide1.xml><?xml version="1.0" encoding="utf-8"?>
-<p:sld xmlns:a="http://schemas.openxmlformats.org/drawingml/2006/main" xmlns:p="http://schemas.openxmlformats.org/presentationml/2006/main" xmlns:r="http://schemas.openxmlformats.org/officeDocument/2006/relationships">
+<p:sld xmlns:a="http://schemas.openxmlformats.org/drawingml/2006/main" xmlns:r="http://schemas.openxmlformats.org/officeDocument/2006/relationships" xmlns:p="http://schemas.openxmlformats.org/presentationml/2006/main">
   <p:cSld>
     <p:spTree>
       <p:nvGrpSpPr>
@@ -3098,7 +3088,14 @@
         <p:cNvGrpSpPr/>
         <p:nvPr/>
       </p:nvGrpSpPr>
-      <p:grpSpPr/>
+      <p:grpSpPr>
+        <a:xfrm>
+          <a:off x="0" y="0"/>
+          <a:ext cx="0" cy="0"/>
+          <a:chOff x="0" y="0"/>
+          <a:chExt cx="0" cy="0"/>
+        </a:xfrm>
+      </p:grpSpPr>
       <p:pic>
         <p:nvPicPr>
           <p:cNvPr id="2" name="Picture 1" descr="slide-001.png"/>
@@ -3163,6 +3160,7 @@
           <a:lstStyle/>
           <a:p>
             <a:pPr algn="ctr"/>
+            <a:endParaRPr/>
           </a:p>
         </p:txBody>
       </p:sp>
@@ -3206,6 +3204,7 @@
           <a:lstStyle/>
           <a:p>
             <a:pPr algn="ctr"/>
+            <a:endParaRPr/>
           </a:p>
         </p:txBody>
       </p:sp>
@@ -3249,6 +3248,7 @@
           <a:lstStyle/>
           <a:p>
             <a:pPr algn="ctr"/>
+            <a:endParaRPr/>
           </a:p>
         </p:txBody>
       </p:sp>
@@ -3292,6 +3292,7 @@
           <a:lstStyle/>
           <a:p>
             <a:pPr algn="ctr"/>
+            <a:endParaRPr/>
           </a:p>
         </p:txBody>
       </p:sp>
@@ -3335,221 +3336,7 @@
           <a:lstStyle/>
           <a:p>
             <a:pPr algn="ctr"/>
-          </a:p>
-        </p:txBody>
-      </p:sp>
-      <p:sp>
-        <p:nvSpPr>
-          <p:cNvPr id="8" name="Rectangle 7">
-            <a:hlinkClick r:id="rId8"/>
-          </p:cNvPr>
-          <p:cNvSpPr/>
-          <p:nvPr/>
-        </p:nvSpPr>
-        <p:spPr>
-          <a:xfrm>
-            <a:off x="10360152" y="3570732"/>
-            <a:ext cx="1143000" cy="182880"/>
-          </a:xfrm>
-          <a:prstGeom prst="rect">
-            <a:avLst/>
-          </a:prstGeom>
-          <a:noFill/>
-          <a:ln>
-            <a:noFill/>
-          </a:ln>
-        </p:spPr>
-        <p:style>
-          <a:lnRef idx="1">
-            <a:schemeClr val="accent1"/>
-          </a:lnRef>
-          <a:fillRef idx="3">
-            <a:schemeClr val="accent1"/>
-          </a:fillRef>
-          <a:effectRef idx="2">
-            <a:schemeClr val="accent1"/>
-          </a:effectRef>
-          <a:fontRef idx="minor">
-            <a:schemeClr val="lt1"/>
-          </a:fontRef>
-        </p:style>
-        <p:txBody>
-          <a:bodyPr rtlCol="0" anchor="ctr"/>
-          <a:lstStyle/>
-          <a:p>
-            <a:pPr algn="ctr"/>
-          </a:p>
-        </p:txBody>
-      </p:sp>
-      <p:sp>
-        <p:nvSpPr>
-          <p:cNvPr id="9" name="Rectangle 8">
-            <a:hlinkClick r:id="rId9"/>
-          </p:cNvPr>
-          <p:cNvSpPr/>
-          <p:nvPr/>
-        </p:nvSpPr>
-        <p:spPr>
-          <a:xfrm>
-            <a:off x="10360152" y="3776472"/>
-            <a:ext cx="1143000" cy="182880"/>
-          </a:xfrm>
-          <a:prstGeom prst="rect">
-            <a:avLst/>
-          </a:prstGeom>
-          <a:noFill/>
-          <a:ln>
-            <a:noFill/>
-          </a:ln>
-        </p:spPr>
-        <p:style>
-          <a:lnRef idx="1">
-            <a:schemeClr val="accent1"/>
-          </a:lnRef>
-          <a:fillRef idx="3">
-            <a:schemeClr val="accent1"/>
-          </a:fillRef>
-          <a:effectRef idx="2">
-            <a:schemeClr val="accent1"/>
-          </a:effectRef>
-          <a:fontRef idx="minor">
-            <a:schemeClr val="lt1"/>
-          </a:fontRef>
-        </p:style>
-        <p:txBody>
-          <a:bodyPr rtlCol="0" anchor="ctr"/>
-          <a:lstStyle/>
-          <a:p>
-            <a:pPr algn="ctr"/>
-          </a:p>
-        </p:txBody>
-      </p:sp>
-      <p:sp>
-        <p:nvSpPr>
-          <p:cNvPr id="10" name="Rectangle 9">
-            <a:hlinkClick r:id="rId10"/>
-          </p:cNvPr>
-          <p:cNvSpPr/>
-          <p:nvPr/>
-        </p:nvSpPr>
-        <p:spPr>
-          <a:xfrm>
-            <a:off x="10360152" y="3982211"/>
-            <a:ext cx="1143000" cy="182880"/>
-          </a:xfrm>
-          <a:prstGeom prst="rect">
-            <a:avLst/>
-          </a:prstGeom>
-          <a:noFill/>
-          <a:ln>
-            <a:noFill/>
-          </a:ln>
-        </p:spPr>
-        <p:style>
-          <a:lnRef idx="1">
-            <a:schemeClr val="accent1"/>
-          </a:lnRef>
-          <a:fillRef idx="3">
-            <a:schemeClr val="accent1"/>
-          </a:fillRef>
-          <a:effectRef idx="2">
-            <a:schemeClr val="accent1"/>
-          </a:effectRef>
-          <a:fontRef idx="minor">
-            <a:schemeClr val="lt1"/>
-          </a:fontRef>
-        </p:style>
-        <p:txBody>
-          <a:bodyPr rtlCol="0" anchor="ctr"/>
-          <a:lstStyle/>
-          <a:p>
-            <a:pPr algn="ctr"/>
-          </a:p>
-        </p:txBody>
-      </p:sp>
-      <p:sp>
-        <p:nvSpPr>
-          <p:cNvPr id="11" name="Rectangle 10">
-            <a:hlinkClick r:id="rId11"/>
-          </p:cNvPr>
-          <p:cNvSpPr/>
-          <p:nvPr/>
-        </p:nvSpPr>
-        <p:spPr>
-          <a:xfrm>
-            <a:off x="10360152" y="4187952"/>
-            <a:ext cx="1143000" cy="182880"/>
-          </a:xfrm>
-          <a:prstGeom prst="rect">
-            <a:avLst/>
-          </a:prstGeom>
-          <a:noFill/>
-          <a:ln>
-            <a:noFill/>
-          </a:ln>
-        </p:spPr>
-        <p:style>
-          <a:lnRef idx="1">
-            <a:schemeClr val="accent1"/>
-          </a:lnRef>
-          <a:fillRef idx="3">
-            <a:schemeClr val="accent1"/>
-          </a:fillRef>
-          <a:effectRef idx="2">
-            <a:schemeClr val="accent1"/>
-          </a:effectRef>
-          <a:fontRef idx="minor">
-            <a:schemeClr val="lt1"/>
-          </a:fontRef>
-        </p:style>
-        <p:txBody>
-          <a:bodyPr rtlCol="0" anchor="ctr"/>
-          <a:lstStyle/>
-          <a:p>
-            <a:pPr algn="ctr"/>
-          </a:p>
-        </p:txBody>
-      </p:sp>
-      <p:sp>
-        <p:nvSpPr>
-          <p:cNvPr id="12" name="Rectangle 11">
-            <a:hlinkClick r:id="rId12"/>
-          </p:cNvPr>
-          <p:cNvSpPr/>
-          <p:nvPr/>
-        </p:nvSpPr>
-        <p:spPr>
-          <a:xfrm>
-            <a:off x="10360152" y="4393692"/>
-            <a:ext cx="1143000" cy="182880"/>
-          </a:xfrm>
-          <a:prstGeom prst="rect">
-            <a:avLst/>
-          </a:prstGeom>
-          <a:noFill/>
-          <a:ln>
-            <a:noFill/>
-          </a:ln>
-        </p:spPr>
-        <p:style>
-          <a:lnRef idx="1">
-            <a:schemeClr val="accent1"/>
-          </a:lnRef>
-          <a:fillRef idx="3">
-            <a:schemeClr val="accent1"/>
-          </a:fillRef>
-          <a:effectRef idx="2">
-            <a:schemeClr val="accent1"/>
-          </a:effectRef>
-          <a:fontRef idx="minor">
-            <a:schemeClr val="lt1"/>
-          </a:fontRef>
-        </p:style>
-        <p:txBody>
-          <a:bodyPr rtlCol="0" anchor="ctr"/>
-          <a:lstStyle/>
-          <a:p>
-            <a:pPr algn="ctr"/>
+            <a:endParaRPr/>
           </a:p>
         </p:txBody>
       </p:sp>
@@ -3561,8 +3348,8 @@
 </p:sld>
 </file>
 
-<file path=ppt/slides/slide10.xml><?xml version="1.0" encoding="utf-8"?>
-<p:sld xmlns:a="http://schemas.openxmlformats.org/drawingml/2006/main" xmlns:p="http://schemas.openxmlformats.org/presentationml/2006/main" xmlns:r="http://schemas.openxmlformats.org/officeDocument/2006/relationships">
+<file path=ppt/slides/slide2.xml><?xml version="1.0" encoding="utf-8"?>
+<p:sld xmlns:a="http://schemas.openxmlformats.org/drawingml/2006/main" xmlns:r="http://schemas.openxmlformats.org/officeDocument/2006/relationships" xmlns:p="http://schemas.openxmlformats.org/presentationml/2006/main">
   <p:cSld>
     <p:spTree>
       <p:nvGrpSpPr>
@@ -3570,10 +3357,17 @@
         <p:cNvGrpSpPr/>
         <p:nvPr/>
       </p:nvGrpSpPr>
-      <p:grpSpPr/>
+      <p:grpSpPr>
+        <a:xfrm>
+          <a:off x="0" y="0"/>
+          <a:ext cx="0" cy="0"/>
+          <a:chOff x="0" y="0"/>
+          <a:chExt cx="0" cy="0"/>
+        </a:xfrm>
+      </p:grpSpPr>
       <p:pic>
         <p:nvPicPr>
-          <p:cNvPr id="2" name="Picture 1" descr="slide-010.png"/>
+          <p:cNvPr id="2" name="Picture 1" descr="slide-002.png"/>
           <p:cNvPicPr>
             <a:picLocks noChangeAspect="1"/>
           </p:cNvPicPr>
@@ -3635,6 +3429,7 @@
           <a:lstStyle/>
           <a:p>
             <a:pPr algn="ctr"/>
+            <a:endParaRPr/>
           </a:p>
         </p:txBody>
       </p:sp>
@@ -3678,6 +3473,7 @@
           <a:lstStyle/>
           <a:p>
             <a:pPr algn="ctr"/>
+            <a:endParaRPr/>
           </a:p>
         </p:txBody>
       </p:sp>
@@ -3689,8 +3485,8 @@
 </p:sld>
 </file>
 
-<file path=ppt/slides/slide11.xml><?xml version="1.0" encoding="utf-8"?>
-<p:sld xmlns:a="http://schemas.openxmlformats.org/drawingml/2006/main" xmlns:p="http://schemas.openxmlformats.org/presentationml/2006/main" xmlns:r="http://schemas.openxmlformats.org/officeDocument/2006/relationships">
+<file path=ppt/slides/slide3.xml><?xml version="1.0" encoding="utf-8"?>
+<p:sld xmlns:a="http://schemas.openxmlformats.org/drawingml/2006/main" xmlns:r="http://schemas.openxmlformats.org/officeDocument/2006/relationships" xmlns:p="http://schemas.openxmlformats.org/presentationml/2006/main">
   <p:cSld>
     <p:spTree>
       <p:nvGrpSpPr>
@@ -3698,10 +3494,17 @@
         <p:cNvGrpSpPr/>
         <p:nvPr/>
       </p:nvGrpSpPr>
-      <p:grpSpPr/>
+      <p:grpSpPr>
+        <a:xfrm>
+          <a:off x="0" y="0"/>
+          <a:ext cx="0" cy="0"/>
+          <a:chOff x="0" y="0"/>
+          <a:chExt cx="0" cy="0"/>
+        </a:xfrm>
+      </p:grpSpPr>
       <p:pic>
         <p:nvPicPr>
-          <p:cNvPr id="2" name="Picture 1" descr="slide-011.png"/>
+          <p:cNvPr id="2" name="Picture 1" descr="slide-003.png"/>
           <p:cNvPicPr>
             <a:picLocks noChangeAspect="1"/>
           </p:cNvPicPr>
@@ -3763,6 +3566,7 @@
           <a:lstStyle/>
           <a:p>
             <a:pPr algn="ctr"/>
+            <a:endParaRPr/>
           </a:p>
         </p:txBody>
       </p:sp>
@@ -3806,6 +3610,7 @@
           <a:lstStyle/>
           <a:p>
             <a:pPr algn="ctr"/>
+            <a:endParaRPr/>
           </a:p>
         </p:txBody>
       </p:sp>
@@ -3817,8 +3622,8 @@
 </p:sld>
 </file>
 
-<file path=ppt/slides/slide12.xml><?xml version="1.0" encoding="utf-8"?>
-<p:sld xmlns:a="http://schemas.openxmlformats.org/drawingml/2006/main" xmlns:p="http://schemas.openxmlformats.org/presentationml/2006/main" xmlns:r="http://schemas.openxmlformats.org/officeDocument/2006/relationships">
+<file path=ppt/slides/slide4.xml><?xml version="1.0" encoding="utf-8"?>
+<p:sld xmlns:a="http://schemas.openxmlformats.org/drawingml/2006/main" xmlns:r="http://schemas.openxmlformats.org/officeDocument/2006/relationships" xmlns:p="http://schemas.openxmlformats.org/presentationml/2006/main">
   <p:cSld>
     <p:spTree>
       <p:nvGrpSpPr>
@@ -3826,52 +3631,17 @@
         <p:cNvGrpSpPr/>
         <p:nvPr/>
       </p:nvGrpSpPr>
-      <p:grpSpPr/>
+      <p:grpSpPr>
+        <a:xfrm>
+          <a:off x="0" y="0"/>
+          <a:ext cx="0" cy="0"/>
+          <a:chOff x="0" y="0"/>
+          <a:chExt cx="0" cy="0"/>
+        </a:xfrm>
+      </p:grpSpPr>
       <p:pic>
         <p:nvPicPr>
-          <p:cNvPr id="2" name="Picture 1" descr="slide-012.png"/>
-          <p:cNvPicPr>
-            <a:picLocks noChangeAspect="1"/>
-          </p:cNvPicPr>
-          <p:nvPr/>
-        </p:nvPicPr>
-        <p:blipFill>
-          <a:blip r:embed="rId2"/>
-          <a:stretch>
-            <a:fillRect/>
-          </a:stretch>
-        </p:blipFill>
-        <p:spPr>
-          <a:xfrm>
-            <a:off x="0" y="0"/>
-            <a:ext cx="12191999" cy="6858000"/>
-          </a:xfrm>
-          <a:prstGeom prst="rect">
-            <a:avLst/>
-          </a:prstGeom>
-        </p:spPr>
-      </p:pic>
-    </p:spTree>
-  </p:cSld>
-  <p:clrMapOvr>
-    <a:masterClrMapping/>
-  </p:clrMapOvr>
-</p:sld>
-</file>
-
-<file path=ppt/slides/slide2.xml><?xml version="1.0" encoding="utf-8"?>
-<p:sld xmlns:a="http://schemas.openxmlformats.org/drawingml/2006/main" xmlns:p="http://schemas.openxmlformats.org/presentationml/2006/main" xmlns:r="http://schemas.openxmlformats.org/officeDocument/2006/relationships">
-  <p:cSld>
-    <p:spTree>
-      <p:nvGrpSpPr>
-        <p:cNvPr id="1" name=""/>
-        <p:cNvGrpSpPr/>
-        <p:nvPr/>
-      </p:nvGrpSpPr>
-      <p:grpSpPr/>
-      <p:pic>
-        <p:nvPicPr>
-          <p:cNvPr id="2" name="Picture 1" descr="slide-002.png"/>
+          <p:cNvPr id="2" name="Picture 1" descr="slide-004.png"/>
           <p:cNvPicPr>
             <a:picLocks noChangeAspect="1"/>
           </p:cNvPicPr>
@@ -3933,6 +3703,7 @@
           <a:lstStyle/>
           <a:p>
             <a:pPr algn="ctr"/>
+            <a:endParaRPr/>
           </a:p>
         </p:txBody>
       </p:sp>
@@ -3976,6 +3747,7 @@
           <a:lstStyle/>
           <a:p>
             <a:pPr algn="ctr"/>
+            <a:endParaRPr/>
           </a:p>
         </p:txBody>
       </p:sp>
@@ -3987,8 +3759,8 @@
 </p:sld>
 </file>
 
-<file path=ppt/slides/slide3.xml><?xml version="1.0" encoding="utf-8"?>
-<p:sld xmlns:a="http://schemas.openxmlformats.org/drawingml/2006/main" xmlns:p="http://schemas.openxmlformats.org/presentationml/2006/main" xmlns:r="http://schemas.openxmlformats.org/officeDocument/2006/relationships">
+<file path=ppt/slides/slide5.xml><?xml version="1.0" encoding="utf-8"?>
+<p:sld xmlns:a="http://schemas.openxmlformats.org/drawingml/2006/main" xmlns:r="http://schemas.openxmlformats.org/officeDocument/2006/relationships" xmlns:p="http://schemas.openxmlformats.org/presentationml/2006/main">
   <p:cSld>
     <p:spTree>
       <p:nvGrpSpPr>
@@ -3996,10 +3768,17 @@
         <p:cNvGrpSpPr/>
         <p:nvPr/>
       </p:nvGrpSpPr>
-      <p:grpSpPr/>
+      <p:grpSpPr>
+        <a:xfrm>
+          <a:off x="0" y="0"/>
+          <a:ext cx="0" cy="0"/>
+          <a:chOff x="0" y="0"/>
+          <a:chExt cx="0" cy="0"/>
+        </a:xfrm>
+      </p:grpSpPr>
       <p:pic>
         <p:nvPicPr>
-          <p:cNvPr id="2" name="Picture 1" descr="slide-003.png"/>
+          <p:cNvPr id="2" name="Picture 1" descr="slide-005.png"/>
           <p:cNvPicPr>
             <a:picLocks noChangeAspect="1"/>
           </p:cNvPicPr>
@@ -4061,6 +3840,7 @@
           <a:lstStyle/>
           <a:p>
             <a:pPr algn="ctr"/>
+            <a:endParaRPr/>
           </a:p>
         </p:txBody>
       </p:sp>
@@ -4104,6 +3884,7 @@
           <a:lstStyle/>
           <a:p>
             <a:pPr algn="ctr"/>
+            <a:endParaRPr/>
           </a:p>
         </p:txBody>
       </p:sp>
@@ -4115,8 +3896,8 @@
 </p:sld>
 </file>
 
-<file path=ppt/slides/slide4.xml><?xml version="1.0" encoding="utf-8"?>
-<p:sld xmlns:a="http://schemas.openxmlformats.org/drawingml/2006/main" xmlns:p="http://schemas.openxmlformats.org/presentationml/2006/main" xmlns:r="http://schemas.openxmlformats.org/officeDocument/2006/relationships">
+<file path=ppt/slides/slide6.xml><?xml version="1.0" encoding="utf-8"?>
+<p:sld xmlns:a="http://schemas.openxmlformats.org/drawingml/2006/main" xmlns:r="http://schemas.openxmlformats.org/officeDocument/2006/relationships" xmlns:p="http://schemas.openxmlformats.org/presentationml/2006/main">
   <p:cSld>
     <p:spTree>
       <p:nvGrpSpPr>
@@ -4124,10 +3905,17 @@
         <p:cNvGrpSpPr/>
         <p:nvPr/>
       </p:nvGrpSpPr>
-      <p:grpSpPr/>
+      <p:grpSpPr>
+        <a:xfrm>
+          <a:off x="0" y="0"/>
+          <a:ext cx="0" cy="0"/>
+          <a:chOff x="0" y="0"/>
+          <a:chExt cx="0" cy="0"/>
+        </a:xfrm>
+      </p:grpSpPr>
       <p:pic>
         <p:nvPicPr>
-          <p:cNvPr id="2" name="Picture 1" descr="slide-004.png"/>
+          <p:cNvPr id="2" name="Picture 1" descr="slide-006.png"/>
           <p:cNvPicPr>
             <a:picLocks noChangeAspect="1"/>
           </p:cNvPicPr>
@@ -4189,6 +3977,7 @@
           <a:lstStyle/>
           <a:p>
             <a:pPr algn="ctr"/>
+            <a:endParaRPr/>
           </a:p>
         </p:txBody>
       </p:sp>
@@ -4232,262 +4021,7 @@
           <a:lstStyle/>
           <a:p>
             <a:pPr algn="ctr"/>
-          </a:p>
-        </p:txBody>
-      </p:sp>
-    </p:spTree>
-  </p:cSld>
-  <p:clrMapOvr>
-    <a:masterClrMapping/>
-  </p:clrMapOvr>
-</p:sld>
-</file>
-
-<file path=ppt/slides/slide5.xml><?xml version="1.0" encoding="utf-8"?>
-<p:sld xmlns:a="http://schemas.openxmlformats.org/drawingml/2006/main" xmlns:p="http://schemas.openxmlformats.org/presentationml/2006/main" xmlns:r="http://schemas.openxmlformats.org/officeDocument/2006/relationships">
-  <p:cSld>
-    <p:spTree>
-      <p:nvGrpSpPr>
-        <p:cNvPr id="1" name=""/>
-        <p:cNvGrpSpPr/>
-        <p:nvPr/>
-      </p:nvGrpSpPr>
-      <p:grpSpPr/>
-      <p:pic>
-        <p:nvPicPr>
-          <p:cNvPr id="2" name="Picture 1" descr="slide-005.png"/>
-          <p:cNvPicPr>
-            <a:picLocks noChangeAspect="1"/>
-          </p:cNvPicPr>
-          <p:nvPr/>
-        </p:nvPicPr>
-        <p:blipFill>
-          <a:blip r:embed="rId2"/>
-          <a:stretch>
-            <a:fillRect/>
-          </a:stretch>
-        </p:blipFill>
-        <p:spPr>
-          <a:xfrm>
-            <a:off x="0" y="0"/>
-            <a:ext cx="12191999" cy="6858000"/>
-          </a:xfrm>
-          <a:prstGeom prst="rect">
-            <a:avLst/>
-          </a:prstGeom>
-        </p:spPr>
-      </p:pic>
-      <p:sp>
-        <p:nvSpPr>
-          <p:cNvPr id="3" name="Rectangle 2">
-            <a:hlinkClick r:id="rId3"/>
-          </p:cNvPr>
-          <p:cNvSpPr/>
-          <p:nvPr/>
-        </p:nvSpPr>
-        <p:spPr>
-          <a:xfrm>
-            <a:off x="9509760" y="384048"/>
-            <a:ext cx="1828800" cy="310896"/>
-          </a:xfrm>
-          <a:prstGeom prst="rect">
-            <a:avLst/>
-          </a:prstGeom>
-          <a:noFill/>
-          <a:ln>
-            <a:noFill/>
-          </a:ln>
-        </p:spPr>
-        <p:style>
-          <a:lnRef idx="1">
-            <a:schemeClr val="accent1"/>
-          </a:lnRef>
-          <a:fillRef idx="3">
-            <a:schemeClr val="accent1"/>
-          </a:fillRef>
-          <a:effectRef idx="2">
-            <a:schemeClr val="accent1"/>
-          </a:effectRef>
-          <a:fontRef idx="minor">
-            <a:schemeClr val="lt1"/>
-          </a:fontRef>
-        </p:style>
-        <p:txBody>
-          <a:bodyPr rtlCol="0" anchor="ctr"/>
-          <a:lstStyle/>
-          <a:p>
-            <a:pPr algn="ctr"/>
-          </a:p>
-        </p:txBody>
-      </p:sp>
-      <p:sp>
-        <p:nvSpPr>
-          <p:cNvPr id="4" name="Rectangle 3">
-            <a:hlinkClick r:id="rId3"/>
-          </p:cNvPr>
-          <p:cNvSpPr/>
-          <p:nvPr/>
-        </p:nvSpPr>
-        <p:spPr>
-          <a:xfrm>
-            <a:off x="6400800" y="6473952"/>
-            <a:ext cx="4937760" cy="201168"/>
-          </a:xfrm>
-          <a:prstGeom prst="rect">
-            <a:avLst/>
-          </a:prstGeom>
-          <a:noFill/>
-          <a:ln>
-            <a:noFill/>
-          </a:ln>
-        </p:spPr>
-        <p:style>
-          <a:lnRef idx="1">
-            <a:schemeClr val="accent1"/>
-          </a:lnRef>
-          <a:fillRef idx="3">
-            <a:schemeClr val="accent1"/>
-          </a:fillRef>
-          <a:effectRef idx="2">
-            <a:schemeClr val="accent1"/>
-          </a:effectRef>
-          <a:fontRef idx="minor">
-            <a:schemeClr val="lt1"/>
-          </a:fontRef>
-        </p:style>
-        <p:txBody>
-          <a:bodyPr rtlCol="0" anchor="ctr"/>
-          <a:lstStyle/>
-          <a:p>
-            <a:pPr algn="ctr"/>
-          </a:p>
-        </p:txBody>
-      </p:sp>
-    </p:spTree>
-  </p:cSld>
-  <p:clrMapOvr>
-    <a:masterClrMapping/>
-  </p:clrMapOvr>
-</p:sld>
-</file>
-
-<file path=ppt/slides/slide6.xml><?xml version="1.0" encoding="utf-8"?>
-<p:sld xmlns:a="http://schemas.openxmlformats.org/drawingml/2006/main" xmlns:p="http://schemas.openxmlformats.org/presentationml/2006/main" xmlns:r="http://schemas.openxmlformats.org/officeDocument/2006/relationships">
-  <p:cSld>
-    <p:spTree>
-      <p:nvGrpSpPr>
-        <p:cNvPr id="1" name=""/>
-        <p:cNvGrpSpPr/>
-        <p:nvPr/>
-      </p:nvGrpSpPr>
-      <p:grpSpPr/>
-      <p:pic>
-        <p:nvPicPr>
-          <p:cNvPr id="2" name="Picture 1" descr="slide-006.png"/>
-          <p:cNvPicPr>
-            <a:picLocks noChangeAspect="1"/>
-          </p:cNvPicPr>
-          <p:nvPr/>
-        </p:nvPicPr>
-        <p:blipFill>
-          <a:blip r:embed="rId2"/>
-          <a:stretch>
-            <a:fillRect/>
-          </a:stretch>
-        </p:blipFill>
-        <p:spPr>
-          <a:xfrm>
-            <a:off x="0" y="0"/>
-            <a:ext cx="12191999" cy="6858000"/>
-          </a:xfrm>
-          <a:prstGeom prst="rect">
-            <a:avLst/>
-          </a:prstGeom>
-        </p:spPr>
-      </p:pic>
-      <p:sp>
-        <p:nvSpPr>
-          <p:cNvPr id="3" name="Rectangle 2">
-            <a:hlinkClick r:id="rId3"/>
-          </p:cNvPr>
-          <p:cNvSpPr/>
-          <p:nvPr/>
-        </p:nvSpPr>
-        <p:spPr>
-          <a:xfrm>
-            <a:off x="9509760" y="384048"/>
-            <a:ext cx="1828800" cy="310896"/>
-          </a:xfrm>
-          <a:prstGeom prst="rect">
-            <a:avLst/>
-          </a:prstGeom>
-          <a:noFill/>
-          <a:ln>
-            <a:noFill/>
-          </a:ln>
-        </p:spPr>
-        <p:style>
-          <a:lnRef idx="1">
-            <a:schemeClr val="accent1"/>
-          </a:lnRef>
-          <a:fillRef idx="3">
-            <a:schemeClr val="accent1"/>
-          </a:fillRef>
-          <a:effectRef idx="2">
-            <a:schemeClr val="accent1"/>
-          </a:effectRef>
-          <a:fontRef idx="minor">
-            <a:schemeClr val="lt1"/>
-          </a:fontRef>
-        </p:style>
-        <p:txBody>
-          <a:bodyPr rtlCol="0" anchor="ctr"/>
-          <a:lstStyle/>
-          <a:p>
-            <a:pPr algn="ctr"/>
-          </a:p>
-        </p:txBody>
-      </p:sp>
-      <p:sp>
-        <p:nvSpPr>
-          <p:cNvPr id="4" name="Rectangle 3">
-            <a:hlinkClick r:id="rId3"/>
-          </p:cNvPr>
-          <p:cNvSpPr/>
-          <p:nvPr/>
-        </p:nvSpPr>
-        <p:spPr>
-          <a:xfrm>
-            <a:off x="6400800" y="6473952"/>
-            <a:ext cx="4937760" cy="201168"/>
-          </a:xfrm>
-          <a:prstGeom prst="rect">
-            <a:avLst/>
-          </a:prstGeom>
-          <a:noFill/>
-          <a:ln>
-            <a:noFill/>
-          </a:ln>
-        </p:spPr>
-        <p:style>
-          <a:lnRef idx="1">
-            <a:schemeClr val="accent1"/>
-          </a:lnRef>
-          <a:fillRef idx="3">
-            <a:schemeClr val="accent1"/>
-          </a:fillRef>
-          <a:effectRef idx="2">
-            <a:schemeClr val="accent1"/>
-          </a:effectRef>
-          <a:fontRef idx="minor">
-            <a:schemeClr val="lt1"/>
-          </a:fontRef>
-        </p:style>
-        <p:txBody>
-          <a:bodyPr rtlCol="0" anchor="ctr"/>
-          <a:lstStyle/>
-          <a:p>
-            <a:pPr algn="ctr"/>
+            <a:endParaRPr/>
           </a:p>
         </p:txBody>
       </p:sp>
@@ -4500,7 +4034,7 @@
 </file>
 
 <file path=ppt/slides/slide7.xml><?xml version="1.0" encoding="utf-8"?>
-<p:sld xmlns:a="http://schemas.openxmlformats.org/drawingml/2006/main" xmlns:p="http://schemas.openxmlformats.org/presentationml/2006/main" xmlns:r="http://schemas.openxmlformats.org/officeDocument/2006/relationships">
+<p:sld xmlns:a="http://schemas.openxmlformats.org/drawingml/2006/main" xmlns:r="http://schemas.openxmlformats.org/officeDocument/2006/relationships" xmlns:p="http://schemas.openxmlformats.org/presentationml/2006/main">
   <p:cSld>
     <p:spTree>
       <p:nvGrpSpPr>
@@ -4508,7 +4042,14 @@
         <p:cNvGrpSpPr/>
         <p:nvPr/>
       </p:nvGrpSpPr>
-      <p:grpSpPr/>
+      <p:grpSpPr>
+        <a:xfrm>
+          <a:off x="0" y="0"/>
+          <a:ext cx="0" cy="0"/>
+          <a:chOff x="0" y="0"/>
+          <a:chExt cx="0" cy="0"/>
+        </a:xfrm>
+      </p:grpSpPr>
       <p:pic>
         <p:nvPicPr>
           <p:cNvPr id="2" name="Picture 1" descr="slide-007.png"/>
@@ -4533,348 +4074,6 @@
           </a:prstGeom>
         </p:spPr>
       </p:pic>
-      <p:sp>
-        <p:nvSpPr>
-          <p:cNvPr id="3" name="Rectangle 2">
-            <a:hlinkClick r:id="rId3"/>
-          </p:cNvPr>
-          <p:cNvSpPr/>
-          <p:nvPr/>
-        </p:nvSpPr>
-        <p:spPr>
-          <a:xfrm>
-            <a:off x="9509760" y="384048"/>
-            <a:ext cx="1828800" cy="310896"/>
-          </a:xfrm>
-          <a:prstGeom prst="rect">
-            <a:avLst/>
-          </a:prstGeom>
-          <a:noFill/>
-          <a:ln>
-            <a:noFill/>
-          </a:ln>
-        </p:spPr>
-        <p:style>
-          <a:lnRef idx="1">
-            <a:schemeClr val="accent1"/>
-          </a:lnRef>
-          <a:fillRef idx="3">
-            <a:schemeClr val="accent1"/>
-          </a:fillRef>
-          <a:effectRef idx="2">
-            <a:schemeClr val="accent1"/>
-          </a:effectRef>
-          <a:fontRef idx="minor">
-            <a:schemeClr val="lt1"/>
-          </a:fontRef>
-        </p:style>
-        <p:txBody>
-          <a:bodyPr rtlCol="0" anchor="ctr"/>
-          <a:lstStyle/>
-          <a:p>
-            <a:pPr algn="ctr"/>
-          </a:p>
-        </p:txBody>
-      </p:sp>
-      <p:sp>
-        <p:nvSpPr>
-          <p:cNvPr id="4" name="Rectangle 3">
-            <a:hlinkClick r:id="rId3"/>
-          </p:cNvPr>
-          <p:cNvSpPr/>
-          <p:nvPr/>
-        </p:nvSpPr>
-        <p:spPr>
-          <a:xfrm>
-            <a:off x="6400800" y="6473952"/>
-            <a:ext cx="4937760" cy="201168"/>
-          </a:xfrm>
-          <a:prstGeom prst="rect">
-            <a:avLst/>
-          </a:prstGeom>
-          <a:noFill/>
-          <a:ln>
-            <a:noFill/>
-          </a:ln>
-        </p:spPr>
-        <p:style>
-          <a:lnRef idx="1">
-            <a:schemeClr val="accent1"/>
-          </a:lnRef>
-          <a:fillRef idx="3">
-            <a:schemeClr val="accent1"/>
-          </a:fillRef>
-          <a:effectRef idx="2">
-            <a:schemeClr val="accent1"/>
-          </a:effectRef>
-          <a:fontRef idx="minor">
-            <a:schemeClr val="lt1"/>
-          </a:fontRef>
-        </p:style>
-        <p:txBody>
-          <a:bodyPr rtlCol="0" anchor="ctr"/>
-          <a:lstStyle/>
-          <a:p>
-            <a:pPr algn="ctr"/>
-          </a:p>
-        </p:txBody>
-      </p:sp>
-    </p:spTree>
-  </p:cSld>
-  <p:clrMapOvr>
-    <a:masterClrMapping/>
-  </p:clrMapOvr>
-</p:sld>
-</file>
-
-<file path=ppt/slides/slide8.xml><?xml version="1.0" encoding="utf-8"?>
-<p:sld xmlns:a="http://schemas.openxmlformats.org/drawingml/2006/main" xmlns:p="http://schemas.openxmlformats.org/presentationml/2006/main" xmlns:r="http://schemas.openxmlformats.org/officeDocument/2006/relationships">
-  <p:cSld>
-    <p:spTree>
-      <p:nvGrpSpPr>
-        <p:cNvPr id="1" name=""/>
-        <p:cNvGrpSpPr/>
-        <p:nvPr/>
-      </p:nvGrpSpPr>
-      <p:grpSpPr/>
-      <p:pic>
-        <p:nvPicPr>
-          <p:cNvPr id="2" name="Picture 1" descr="slide-008.png"/>
-          <p:cNvPicPr>
-            <a:picLocks noChangeAspect="1"/>
-          </p:cNvPicPr>
-          <p:nvPr/>
-        </p:nvPicPr>
-        <p:blipFill>
-          <a:blip r:embed="rId2"/>
-          <a:stretch>
-            <a:fillRect/>
-          </a:stretch>
-        </p:blipFill>
-        <p:spPr>
-          <a:xfrm>
-            <a:off x="0" y="0"/>
-            <a:ext cx="12191999" cy="6858000"/>
-          </a:xfrm>
-          <a:prstGeom prst="rect">
-            <a:avLst/>
-          </a:prstGeom>
-        </p:spPr>
-      </p:pic>
-      <p:sp>
-        <p:nvSpPr>
-          <p:cNvPr id="3" name="Rectangle 2">
-            <a:hlinkClick r:id="rId3"/>
-          </p:cNvPr>
-          <p:cNvSpPr/>
-          <p:nvPr/>
-        </p:nvSpPr>
-        <p:spPr>
-          <a:xfrm>
-            <a:off x="9509760" y="384048"/>
-            <a:ext cx="1828800" cy="310896"/>
-          </a:xfrm>
-          <a:prstGeom prst="rect">
-            <a:avLst/>
-          </a:prstGeom>
-          <a:noFill/>
-          <a:ln>
-            <a:noFill/>
-          </a:ln>
-        </p:spPr>
-        <p:style>
-          <a:lnRef idx="1">
-            <a:schemeClr val="accent1"/>
-          </a:lnRef>
-          <a:fillRef idx="3">
-            <a:schemeClr val="accent1"/>
-          </a:fillRef>
-          <a:effectRef idx="2">
-            <a:schemeClr val="accent1"/>
-          </a:effectRef>
-          <a:fontRef idx="minor">
-            <a:schemeClr val="lt1"/>
-          </a:fontRef>
-        </p:style>
-        <p:txBody>
-          <a:bodyPr rtlCol="0" anchor="ctr"/>
-          <a:lstStyle/>
-          <a:p>
-            <a:pPr algn="ctr"/>
-          </a:p>
-        </p:txBody>
-      </p:sp>
-      <p:sp>
-        <p:nvSpPr>
-          <p:cNvPr id="4" name="Rectangle 3">
-            <a:hlinkClick r:id="rId3"/>
-          </p:cNvPr>
-          <p:cNvSpPr/>
-          <p:nvPr/>
-        </p:nvSpPr>
-        <p:spPr>
-          <a:xfrm>
-            <a:off x="6400800" y="6473952"/>
-            <a:ext cx="4937760" cy="201168"/>
-          </a:xfrm>
-          <a:prstGeom prst="rect">
-            <a:avLst/>
-          </a:prstGeom>
-          <a:noFill/>
-          <a:ln>
-            <a:noFill/>
-          </a:ln>
-        </p:spPr>
-        <p:style>
-          <a:lnRef idx="1">
-            <a:schemeClr val="accent1"/>
-          </a:lnRef>
-          <a:fillRef idx="3">
-            <a:schemeClr val="accent1"/>
-          </a:fillRef>
-          <a:effectRef idx="2">
-            <a:schemeClr val="accent1"/>
-          </a:effectRef>
-          <a:fontRef idx="minor">
-            <a:schemeClr val="lt1"/>
-          </a:fontRef>
-        </p:style>
-        <p:txBody>
-          <a:bodyPr rtlCol="0" anchor="ctr"/>
-          <a:lstStyle/>
-          <a:p>
-            <a:pPr algn="ctr"/>
-          </a:p>
-        </p:txBody>
-      </p:sp>
-    </p:spTree>
-  </p:cSld>
-  <p:clrMapOvr>
-    <a:masterClrMapping/>
-  </p:clrMapOvr>
-</p:sld>
-</file>
-
-<file path=ppt/slides/slide9.xml><?xml version="1.0" encoding="utf-8"?>
-<p:sld xmlns:a="http://schemas.openxmlformats.org/drawingml/2006/main" xmlns:p="http://schemas.openxmlformats.org/presentationml/2006/main" xmlns:r="http://schemas.openxmlformats.org/officeDocument/2006/relationships">
-  <p:cSld>
-    <p:spTree>
-      <p:nvGrpSpPr>
-        <p:cNvPr id="1" name=""/>
-        <p:cNvGrpSpPr/>
-        <p:nvPr/>
-      </p:nvGrpSpPr>
-      <p:grpSpPr/>
-      <p:pic>
-        <p:nvPicPr>
-          <p:cNvPr id="2" name="Picture 1" descr="slide-009.png"/>
-          <p:cNvPicPr>
-            <a:picLocks noChangeAspect="1"/>
-          </p:cNvPicPr>
-          <p:nvPr/>
-        </p:nvPicPr>
-        <p:blipFill>
-          <a:blip r:embed="rId2"/>
-          <a:stretch>
-            <a:fillRect/>
-          </a:stretch>
-        </p:blipFill>
-        <p:spPr>
-          <a:xfrm>
-            <a:off x="0" y="0"/>
-            <a:ext cx="12191999" cy="6858000"/>
-          </a:xfrm>
-          <a:prstGeom prst="rect">
-            <a:avLst/>
-          </a:prstGeom>
-        </p:spPr>
-      </p:pic>
-      <p:sp>
-        <p:nvSpPr>
-          <p:cNvPr id="3" name="Rectangle 2">
-            <a:hlinkClick r:id="rId3"/>
-          </p:cNvPr>
-          <p:cNvSpPr/>
-          <p:nvPr/>
-        </p:nvSpPr>
-        <p:spPr>
-          <a:xfrm>
-            <a:off x="9509760" y="384048"/>
-            <a:ext cx="1828800" cy="310896"/>
-          </a:xfrm>
-          <a:prstGeom prst="rect">
-            <a:avLst/>
-          </a:prstGeom>
-          <a:noFill/>
-          <a:ln>
-            <a:noFill/>
-          </a:ln>
-        </p:spPr>
-        <p:style>
-          <a:lnRef idx="1">
-            <a:schemeClr val="accent1"/>
-          </a:lnRef>
-          <a:fillRef idx="3">
-            <a:schemeClr val="accent1"/>
-          </a:fillRef>
-          <a:effectRef idx="2">
-            <a:schemeClr val="accent1"/>
-          </a:effectRef>
-          <a:fontRef idx="minor">
-            <a:schemeClr val="lt1"/>
-          </a:fontRef>
-        </p:style>
-        <p:txBody>
-          <a:bodyPr rtlCol="0" anchor="ctr"/>
-          <a:lstStyle/>
-          <a:p>
-            <a:pPr algn="ctr"/>
-          </a:p>
-        </p:txBody>
-      </p:sp>
-      <p:sp>
-        <p:nvSpPr>
-          <p:cNvPr id="4" name="Rectangle 3">
-            <a:hlinkClick r:id="rId3"/>
-          </p:cNvPr>
-          <p:cNvSpPr/>
-          <p:nvPr/>
-        </p:nvSpPr>
-        <p:spPr>
-          <a:xfrm>
-            <a:off x="6400800" y="6473952"/>
-            <a:ext cx="4937760" cy="201168"/>
-          </a:xfrm>
-          <a:prstGeom prst="rect">
-            <a:avLst/>
-          </a:prstGeom>
-          <a:noFill/>
-          <a:ln>
-            <a:noFill/>
-          </a:ln>
-        </p:spPr>
-        <p:style>
-          <a:lnRef idx="1">
-            <a:schemeClr val="accent1"/>
-          </a:lnRef>
-          <a:fillRef idx="3">
-            <a:schemeClr val="accent1"/>
-          </a:fillRef>
-          <a:effectRef idx="2">
-            <a:schemeClr val="accent1"/>
-          </a:effectRef>
-          <a:fontRef idx="minor">
-            <a:schemeClr val="lt1"/>
-          </a:fontRef>
-        </p:style>
-        <p:txBody>
-          <a:bodyPr rtlCol="0" anchor="ctr"/>
-          <a:lstStyle/>
-          <a:p>
-            <a:pPr algn="ctr"/>
-          </a:p>
-        </p:txBody>
-      </p:sp>
     </p:spTree>
   </p:cSld>
   <p:clrMapOvr>

</xml_diff>